<commit_message>
Bump body text to >=18pt for readability
Raise all body prose (bullets, point lists, result lines, descriptions,
diagram labels, numbered steps, summary italics, bilingual slide notes
targets) to >=18pt across both decks. Code blocks, terminal output,
footers/page numbers, eyebrow labels, the Key-Terms reference cards and
the Summary table cells stay compact by design.

Co-Authored-By: Claude Opus 4.8 <noreply@anthropic.com>
</commit_message>
<xml_diff>
--- a/report.pptx
+++ b/report.pptx
@@ -2278,7 +2278,7 @@
               <a:buNone/>
             </a:pPr>
             <a:r>
-              <a:rPr lang="en-US" sz="1500" i="1" dirty="0">
+              <a:rPr lang="en-US" sz="1800" i="1" dirty="0">
                 <a:solidFill>
                   <a:srgbClr val="9AA7B5"/>
                 </a:solidFill>
@@ -2288,7 +2288,7 @@
               </a:rPr>
               <a:t>A live demonstration in an isolated Docker sandbox</a:t>
             </a:r>
-            <a:endParaRPr lang="en-US" sz="1500" dirty="0"/>
+            <a:endParaRPr lang="en-US" sz="1800" dirty="0"/>
           </a:p>
         </p:txBody>
       </p:sp>
@@ -2507,7 +2507,7 @@
               <a:buNone/>
             </a:pPr>
             <a:r>
-              <a:rPr lang="en-US" sz="1500" dirty="0">
+              <a:rPr lang="en-US" sz="1800" dirty="0">
                 <a:solidFill>
                   <a:srgbClr val="F5B82E"/>
                 </a:solidFill>
@@ -2517,7 +2517,7 @@
               </a:rPr>
               <a:t>從語言層根絕:編譯期擋下,或執行期安全中止</a:t>
             </a:r>
-            <a:endParaRPr lang="en-US" sz="1500" dirty="0"/>
+            <a:endParaRPr lang="en-US" sz="1800" dirty="0"/>
           </a:p>
         </p:txBody>
       </p:sp>
@@ -2573,7 +2573,7 @@
               <a:buNone/>
             </a:pPr>
             <a:r>
-              <a:rPr lang="en-US" sz="1600" b="1" dirty="0">
+              <a:rPr lang="en-US" sz="1800" b="1" dirty="0">
                 <a:solidFill>
                   <a:srgbClr val="FF5C57"/>
                 </a:solidFill>
@@ -2583,7 +2583,7 @@
               </a:rPr>
               <a:t>C — strcpy()</a:t>
             </a:r>
-            <a:endParaRPr lang="en-US" sz="1600" dirty="0"/>
+            <a:endParaRPr lang="en-US" sz="1800" dirty="0"/>
           </a:p>
         </p:txBody>
       </p:sp>
@@ -2701,7 +2701,7 @@
               <a:buNone/>
             </a:pPr>
             <a:r>
-              <a:rPr lang="en-US" sz="1400" b="1" dirty="0">
+              <a:rPr lang="en-US" sz="1800" b="1" dirty="0">
                 <a:solidFill>
                   <a:srgbClr val="FF5C57"/>
                 </a:solidFill>
@@ -2715,7 +2715,7 @@
               <a:buNone/>
             </a:pPr>
             <a:r>
-              <a:rPr lang="en-US" sz="1400" dirty="0">
+              <a:rPr lang="en-US" sz="1800" dirty="0">
                 <a:solidFill>
                   <a:srgbClr val="F5F7FA"/>
                 </a:solidFill>
@@ -2725,7 +2725,7 @@
               </a:rPr>
               <a:t>stack smashed</a:t>
             </a:r>
-            <a:endParaRPr lang="en-US" sz="1400" dirty="0"/>
+            <a:endParaRPr lang="en-US" sz="1800" dirty="0"/>
           </a:p>
         </p:txBody>
       </p:sp>
@@ -2754,7 +2754,7 @@
               <a:buNone/>
             </a:pPr>
             <a:r>
-              <a:rPr lang="en-US" sz="1400" b="1" dirty="0">
+              <a:rPr lang="en-US" sz="1800" b="1" dirty="0">
                 <a:solidFill>
                   <a:srgbClr val="FF5C57"/>
                 </a:solidFill>
@@ -2768,7 +2768,7 @@
               <a:buNone/>
             </a:pPr>
             <a:r>
-              <a:rPr lang="en-US" sz="1400" dirty="0">
+              <a:rPr lang="en-US" sz="1800" dirty="0">
                 <a:solidFill>
                   <a:srgbClr val="F5F7FA"/>
                 </a:solidFill>
@@ -2778,7 +2778,7 @@
               </a:rPr>
               <a:t>exit 139 · undefined behavior</a:t>
             </a:r>
-            <a:endParaRPr lang="en-US" sz="1400" dirty="0"/>
+            <a:endParaRPr lang="en-US" sz="1800" dirty="0"/>
           </a:p>
         </p:txBody>
       </p:sp>
@@ -2807,7 +2807,7 @@
               <a:buNone/>
             </a:pPr>
             <a:r>
-              <a:rPr lang="en-US" sz="1400" b="1" dirty="0">
+              <a:rPr lang="en-US" sz="1800" b="1" dirty="0">
                 <a:solidFill>
                   <a:srgbClr val="FF5C57"/>
                 </a:solidFill>
@@ -2821,7 +2821,7 @@
               <a:buNone/>
             </a:pPr>
             <a:r>
-              <a:rPr lang="en-US" sz="1400" b="1" dirty="0">
+              <a:rPr lang="en-US" sz="1800" b="1" dirty="0">
                 <a:solidFill>
                   <a:srgbClr val="FF5C57"/>
                 </a:solidFill>
@@ -2831,7 +2831,7 @@
               </a:rPr>
               <a:t>可被利用(RCE 風險)</a:t>
             </a:r>
-            <a:endParaRPr lang="en-US" sz="1400" dirty="0"/>
+            <a:endParaRPr lang="en-US" sz="1800" dirty="0"/>
           </a:p>
         </p:txBody>
       </p:sp>
@@ -2887,7 +2887,7 @@
               <a:buNone/>
             </a:pPr>
             <a:r>
-              <a:rPr lang="en-US" sz="1600" b="1" dirty="0">
+              <a:rPr lang="en-US" sz="1800" b="1" dirty="0">
                 <a:solidFill>
                   <a:srgbClr val="4FD98A"/>
                 </a:solidFill>
@@ -2897,7 +2897,7 @@
               </a:rPr>
               <a:t>Rust — memory-safe</a:t>
             </a:r>
-            <a:endParaRPr lang="en-US" sz="1600" dirty="0"/>
+            <a:endParaRPr lang="en-US" sz="1800" dirty="0"/>
           </a:p>
         </p:txBody>
       </p:sp>
@@ -3031,7 +3031,7 @@
               <a:buNone/>
             </a:pPr>
             <a:r>
-              <a:rPr lang="en-US" sz="1200" b="1" dirty="0">
+              <a:rPr lang="en-US" sz="1800" b="1" dirty="0">
                 <a:solidFill>
                   <a:srgbClr val="F5B82E"/>
                 </a:solidFill>
@@ -3041,7 +3041,7 @@
               </a:rPr>
               <a:t>rustc error: index out of bounds → 不產出 binary</a:t>
             </a:r>
-            <a:endParaRPr lang="en-US" sz="1200" dirty="0"/>
+            <a:endParaRPr lang="en-US" sz="1800" dirty="0"/>
           </a:p>
         </p:txBody>
       </p:sp>
@@ -3175,7 +3175,7 @@
               <a:buNone/>
             </a:pPr>
             <a:r>
-              <a:rPr lang="en-US" sz="1200" b="1" dirty="0">
+              <a:rPr lang="en-US" sz="1800" b="1" dirty="0">
                 <a:solidFill>
                   <a:srgbClr val="4FD98A"/>
                 </a:solidFill>
@@ -3185,7 +3185,7 @@
               </a:rPr>
               <a:t>safe panic · exit 101 · 無記憶體破壞</a:t>
             </a:r>
-            <a:endParaRPr lang="en-US" sz="1200" dirty="0"/>
+            <a:endParaRPr lang="en-US" sz="1800" dirty="0"/>
           </a:p>
         </p:txBody>
       </p:sp>
@@ -3214,7 +3214,7 @@
               <a:buNone/>
             </a:pPr>
             <a:r>
-              <a:rPr lang="en-US" sz="1300" i="1" dirty="0">
+              <a:rPr lang="en-US" sz="1800" i="1" dirty="0">
                 <a:solidFill>
                   <a:srgbClr val="9AA7B5"/>
                 </a:solidFill>
@@ -3224,7 +3224,7 @@
               </a:rPr>
               <a:t>記憶體安全語言把整類漏洞從『可被利用』變成『編不出來 / 安全中止』 —— Android、Windows、Linux kernel 正加速採用 Rust。</a:t>
             </a:r>
-            <a:endParaRPr lang="en-US" sz="1300" dirty="0"/>
+            <a:endParaRPr lang="en-US" sz="1800" dirty="0"/>
           </a:p>
         </p:txBody>
       </p:sp>
@@ -3441,7 +3441,7 @@
               <a:buNone/>
             </a:pPr>
             <a:r>
-              <a:rPr lang="en-US" sz="1500" dirty="0">
+              <a:rPr lang="en-US" sz="1800" dirty="0">
                 <a:solidFill>
                   <a:srgbClr val="F5B82E"/>
                 </a:solidFill>
@@ -3451,7 +3451,7 @@
               </a:rPr>
               <a:t>Spectre/Meltdown 核心 Flush+Reload —— 不碰記憶體、不崩潰,純靠時間差偷資料</a:t>
             </a:r>
-            <a:endParaRPr lang="en-US" sz="1500" dirty="0"/>
+            <a:endParaRPr lang="en-US" sz="1800" dirty="0"/>
           </a:p>
         </p:txBody>
       </p:sp>
@@ -3777,7 +3777,7 @@
               <a:buNone/>
             </a:pPr>
             <a:r>
-              <a:rPr lang="en-US" sz="1600" b="1" dirty="0">
+              <a:rPr lang="en-US" sz="1800" b="1" dirty="0">
                 <a:solidFill>
                   <a:srgbClr val="5AA9E6"/>
                 </a:solidFill>
@@ -3787,7 +3787,7 @@
               </a:rPr>
               <a:t>Flush + Reload</a:t>
             </a:r>
-            <a:endParaRPr lang="en-US" sz="1600" dirty="0"/>
+            <a:endParaRPr lang="en-US" sz="1800" dirty="0"/>
           </a:p>
         </p:txBody>
       </p:sp>
@@ -3836,7 +3836,7 @@
               <a:buNone/>
             </a:pPr>
             <a:r>
-              <a:rPr lang="en-US" sz="1600" b="1" dirty="0">
+              <a:rPr lang="en-US" sz="1800" b="1" dirty="0">
                 <a:solidFill>
                   <a:srgbClr val="12161C"/>
                 </a:solidFill>
@@ -3846,7 +3846,7 @@
               </a:rPr>
               <a:t>1</a:t>
             </a:r>
-            <a:endParaRPr lang="en-US" sz="1600" dirty="0"/>
+            <a:endParaRPr lang="en-US" sz="1800" dirty="0"/>
           </a:p>
         </p:txBody>
       </p:sp>
@@ -3875,7 +3875,7 @@
               <a:buNone/>
             </a:pPr>
             <a:r>
-              <a:rPr lang="en-US" sz="1400" dirty="0">
+              <a:rPr lang="en-US" sz="1800" dirty="0">
                 <a:solidFill>
                   <a:srgbClr val="F5F7FA"/>
                 </a:solidFill>
@@ -3885,7 +3885,7 @@
               </a:rPr>
               <a:t>Flush —— 把快取清空(evict)</a:t>
             </a:r>
-            <a:endParaRPr lang="en-US" sz="1400" dirty="0"/>
+            <a:endParaRPr lang="en-US" sz="1800" dirty="0"/>
           </a:p>
         </p:txBody>
       </p:sp>
@@ -3934,7 +3934,7 @@
               <a:buNone/>
             </a:pPr>
             <a:r>
-              <a:rPr lang="en-US" sz="1600" b="1" dirty="0">
+              <a:rPr lang="en-US" sz="1800" b="1" dirty="0">
                 <a:solidFill>
                   <a:srgbClr val="12161C"/>
                 </a:solidFill>
@@ -3944,7 +3944,7 @@
               </a:rPr>
               <a:t>2</a:t>
             </a:r>
-            <a:endParaRPr lang="en-US" sz="1600" dirty="0"/>
+            <a:endParaRPr lang="en-US" sz="1800" dirty="0"/>
           </a:p>
         </p:txBody>
       </p:sp>
@@ -3973,7 +3973,7 @@
               <a:buNone/>
             </a:pPr>
             <a:r>
-              <a:rPr lang="en-US" sz="1400" dirty="0">
+              <a:rPr lang="en-US" sz="1800" dirty="0">
                 <a:solidFill>
                   <a:srgbClr val="F5F7FA"/>
                 </a:solidFill>
@@ -3983,7 +3983,7 @@
               </a:rPr>
               <a:t>Victim —— 存取 secret[i],只有它被載入快取</a:t>
             </a:r>
-            <a:endParaRPr lang="en-US" sz="1400" dirty="0"/>
+            <a:endParaRPr lang="en-US" sz="1800" dirty="0"/>
           </a:p>
         </p:txBody>
       </p:sp>
@@ -4032,7 +4032,7 @@
               <a:buNone/>
             </a:pPr>
             <a:r>
-              <a:rPr lang="en-US" sz="1600" b="1" dirty="0">
+              <a:rPr lang="en-US" sz="1800" b="1" dirty="0">
                 <a:solidFill>
                   <a:srgbClr val="12161C"/>
                 </a:solidFill>
@@ -4042,7 +4042,7 @@
               </a:rPr>
               <a:t>3</a:t>
             </a:r>
-            <a:endParaRPr lang="en-US" sz="1600" dirty="0"/>
+            <a:endParaRPr lang="en-US" sz="1800" dirty="0"/>
           </a:p>
         </p:txBody>
       </p:sp>
@@ -4071,7 +4071,7 @@
               <a:buNone/>
             </a:pPr>
             <a:r>
-              <a:rPr lang="en-US" sz="1400" dirty="0">
+              <a:rPr lang="en-US" sz="1800" dirty="0">
                 <a:solidFill>
                   <a:srgbClr val="F5F7FA"/>
                 </a:solidFill>
@@ -4081,7 +4081,7 @@
               </a:rPr>
               <a:t>Reload —— 逐槽計時,最快(命中)那個 = secret</a:t>
             </a:r>
-            <a:endParaRPr lang="en-US" sz="1400" dirty="0"/>
+            <a:endParaRPr lang="en-US" sz="1800" dirty="0"/>
           </a:p>
         </p:txBody>
       </p:sp>
@@ -4193,7 +4193,7 @@
               <a:buNone/>
             </a:pPr>
             <a:r>
-              <a:rPr lang="en-US" sz="1300" i="1" dirty="0">
+              <a:rPr lang="en-US" sz="1800" i="1" dirty="0">
                 <a:solidFill>
                   <a:srgbClr val="9AA7B5"/>
                 </a:solidFill>
@@ -4203,7 +4203,7 @@
               </a:rPr>
               <a:t>Canary / ASLR / DEP·NX 對它無效 —— 微架構本身就是攻擊面,打破『要破壞記憶體才能偷資料』的迷思。</a:t>
             </a:r>
-            <a:endParaRPr lang="en-US" sz="1300" dirty="0"/>
+            <a:endParaRPr lang="en-US" sz="1800" dirty="0"/>
           </a:p>
         </p:txBody>
       </p:sp>
@@ -4420,7 +4420,7 @@
               <a:buNone/>
             </a:pPr>
             <a:r>
-              <a:rPr lang="en-US" sz="1500" dirty="0">
+              <a:rPr lang="en-US" sz="1800" dirty="0">
                 <a:solidFill>
                   <a:srgbClr val="F5B82E"/>
                 </a:solidFill>
@@ -4430,7 +4430,7 @@
               </a:rPr>
               <a:t>四個實作總表 —— 從攻擊到防禦</a:t>
             </a:r>
-            <a:endParaRPr lang="en-US" sz="1500" dirty="0"/>
+            <a:endParaRPr lang="en-US" sz="1800" dirty="0"/>
           </a:p>
         </p:txBody>
       </p:sp>
@@ -5703,7 +5703,7 @@
               <a:buNone/>
             </a:pPr>
             <a:r>
-              <a:rPr lang="en-US" sz="1300" i="1" dirty="0">
+              <a:rPr lang="en-US" sz="1800" i="1" dirty="0">
                 <a:solidFill>
                   <a:srgbClr val="9AA7B5"/>
                 </a:solidFill>
@@ -5713,7 +5713,7 @@
               </a:rPr>
               <a:t>一條線:製造漏洞 → 修補 → 語言根絕 → 微架構側信道 —— 攻防兩面全涵蓋。</a:t>
             </a:r>
-            <a:endParaRPr lang="en-US" sz="1300" dirty="0"/>
+            <a:endParaRPr lang="en-US" sz="1800" dirty="0"/>
           </a:p>
         </p:txBody>
       </p:sp>
@@ -5930,7 +5930,7 @@
               <a:buNone/>
             </a:pPr>
             <a:r>
-              <a:rPr lang="en-US" sz="1500" dirty="0">
+              <a:rPr lang="en-US" sz="1800" dirty="0">
                 <a:solidFill>
                   <a:srgbClr val="F5B82E"/>
                 </a:solidFill>
@@ -5940,7 +5940,7 @@
               </a:rPr>
               <a:t>結論與重點</a:t>
             </a:r>
-            <a:endParaRPr lang="en-US" sz="1500" dirty="0"/>
+            <a:endParaRPr lang="en-US" sz="1800" dirty="0"/>
           </a:p>
         </p:txBody>
       </p:sp>
@@ -6035,7 +6035,7 @@
               <a:buNone/>
             </a:pPr>
             <a:r>
-              <a:rPr lang="en-US" sz="1700" dirty="0">
+              <a:rPr lang="en-US" sz="1800" dirty="0">
                 <a:solidFill>
                   <a:srgbClr val="F5F7FA"/>
                 </a:solidFill>
@@ -6045,7 +6045,7 @@
               </a:rPr>
               <a:t>SIGSEGV</a:t>
             </a:r>
-            <a:endParaRPr lang="en-US" sz="1700" dirty="0"/>
+            <a:endParaRPr lang="en-US" sz="1800" dirty="0"/>
           </a:p>
         </p:txBody>
       </p:sp>
@@ -6074,7 +6074,7 @@
               <a:buNone/>
             </a:pPr>
             <a:r>
-              <a:rPr lang="en-US" sz="1500" dirty="0">
+              <a:rPr lang="en-US" sz="1800" dirty="0">
                 <a:solidFill>
                   <a:srgbClr val="9AA7B5"/>
                 </a:solidFill>
@@ -6084,7 +6084,7 @@
               </a:rPr>
               <a:t>No canary · 回傳位址被無聲覆寫 → 不受控的記憶體錯誤</a:t>
             </a:r>
-            <a:endParaRPr lang="en-US" sz="1500" dirty="0"/>
+            <a:endParaRPr lang="en-US" sz="1800" dirty="0"/>
           </a:p>
         </p:txBody>
       </p:sp>
@@ -6179,7 +6179,7 @@
               <a:buNone/>
             </a:pPr>
             <a:r>
-              <a:rPr lang="en-US" sz="1700" dirty="0">
+              <a:rPr lang="en-US" sz="1800" dirty="0">
                 <a:solidFill>
                   <a:srgbClr val="F5F7FA"/>
                 </a:solidFill>
@@ -6189,7 +6189,7 @@
               </a:rPr>
               <a:t>SIGABRT</a:t>
             </a:r>
-            <a:endParaRPr lang="en-US" sz="1700" dirty="0"/>
+            <a:endParaRPr lang="en-US" sz="1800" dirty="0"/>
           </a:p>
         </p:txBody>
       </p:sp>
@@ -6218,7 +6218,7 @@
               <a:buNone/>
             </a:pPr>
             <a:r>
-              <a:rPr lang="en-US" sz="1500" dirty="0">
+              <a:rPr lang="en-US" sz="1800" dirty="0">
                 <a:solidFill>
                   <a:srgbClr val="9AA7B5"/>
                 </a:solidFill>
@@ -6228,7 +6228,7 @@
               </a:rPr>
               <a:t>Canary on · return 前抓到竄改 → 主動、乾淨地中止</a:t>
             </a:r>
-            <a:endParaRPr lang="en-US" sz="1500" dirty="0"/>
+            <a:endParaRPr lang="en-US" sz="1800" dirty="0"/>
           </a:p>
         </p:txBody>
       </p:sp>
@@ -6261,7 +6261,7 @@
               <a:buChar char="•"/>
             </a:pPr>
             <a:r>
-              <a:rPr lang="en-US" sz="1500" dirty="0">
+              <a:rPr lang="en-US" sz="1800" dirty="0">
                 <a:solidFill>
                   <a:srgbClr val="F5F7FA"/>
                 </a:solidFill>
@@ -6271,7 +6271,7 @@
               </a:rPr>
               <a:t>兩種版本都會崩潰 —— 差別在『主動中止』 vs 『不受控錯誤』</a:t>
             </a:r>
-            <a:endParaRPr lang="en-US" sz="1500" dirty="0"/>
+            <a:endParaRPr lang="en-US" sz="1800" dirty="0"/>
           </a:p>
           <a:p>
             <a:pPr algn="l" marL="342900" indent="-342900">
@@ -6282,7 +6282,7 @@
               <a:buChar char="•"/>
             </a:pPr>
             <a:r>
-              <a:rPr lang="en-US" sz="1500" dirty="0">
+              <a:rPr lang="en-US" sz="1800" dirty="0">
                 <a:solidFill>
                   <a:srgbClr val="F5F7FA"/>
                 </a:solidFill>
@@ -6292,7 +6292,7 @@
               </a:rPr>
               <a:t>防護不是防止崩潰,而是阻止被竄改的回傳位址真正被使用</a:t>
             </a:r>
-            <a:endParaRPr lang="en-US" sz="1500" dirty="0"/>
+            <a:endParaRPr lang="en-US" sz="1800" dirty="0"/>
           </a:p>
           <a:p>
             <a:pPr algn="l" marL="342900" indent="-342900">
@@ -6303,7 +6303,7 @@
               <a:buChar char="•"/>
             </a:pPr>
             <a:r>
-              <a:rPr lang="en-US" sz="1500" dirty="0">
+              <a:rPr lang="en-US" sz="1800" dirty="0">
                 <a:solidFill>
                   <a:srgbClr val="F5F7FA"/>
                 </a:solidFill>
@@ -6313,7 +6313,7 @@
               </a:rPr>
               <a:t>縱深防禦把 RCE 降級成 DoS;安全寫法 (如 strncpy / 邊界檢查) 才是根治</a:t>
             </a:r>
-            <a:endParaRPr lang="en-US" sz="1500" dirty="0"/>
+            <a:endParaRPr lang="en-US" sz="1800" dirty="0"/>
           </a:p>
         </p:txBody>
       </p:sp>
@@ -6544,7 +6544,7 @@
               <a:buNone/>
             </a:pPr>
             <a:r>
-              <a:rPr lang="en-US" sz="1500" dirty="0">
+              <a:rPr lang="en-US" sz="1800" dirty="0">
                 <a:solidFill>
                   <a:srgbClr val="5AA9E6"/>
                 </a:solidFill>
@@ -6554,7 +6554,7 @@
               </a:rPr>
               <a:t>延伸:記憶體與硬體之外,今天最新的攻擊面是 AI / LLM</a:t>
             </a:r>
-            <a:endParaRPr lang="en-US" sz="1500" dirty="0"/>
+            <a:endParaRPr lang="en-US" sz="1800" dirty="0"/>
           </a:p>
         </p:txBody>
       </p:sp>
@@ -6669,7 +6669,7 @@
               <a:buNone/>
             </a:pPr>
             <a:r>
-              <a:rPr lang="en-US" sz="1500" b="1" dirty="0">
+              <a:rPr lang="en-US" sz="1800" b="1" dirty="0">
                 <a:solidFill>
                   <a:srgbClr val="FF5C57"/>
                 </a:solidFill>
@@ -6679,7 +6679,7 @@
               </a:rPr>
               <a:t>Buffer overflow</a:t>
             </a:r>
-            <a:endParaRPr lang="en-US" sz="1500" dirty="0"/>
+            <a:endParaRPr lang="en-US" sz="1800" dirty="0"/>
           </a:p>
         </p:txBody>
       </p:sp>
@@ -6708,7 +6708,7 @@
               <a:buNone/>
             </a:pPr>
             <a:r>
-              <a:rPr lang="en-US" sz="1300" dirty="0">
+              <a:rPr lang="en-US" sz="1800" dirty="0">
                 <a:solidFill>
                   <a:srgbClr val="F5F7FA"/>
                 </a:solidFill>
@@ -6718,7 +6718,7 @@
               </a:rPr>
               <a:t>資料蓋掉回傳位址 → 奪取控制</a:t>
             </a:r>
-            <a:endParaRPr lang="en-US" sz="1300" dirty="0"/>
+            <a:endParaRPr lang="en-US" sz="1800" dirty="0"/>
           </a:p>
         </p:txBody>
       </p:sp>
@@ -6767,7 +6767,7 @@
               <a:buNone/>
             </a:pPr>
             <a:r>
-              <a:rPr lang="en-US" sz="1500" b="1" dirty="0">
+              <a:rPr lang="en-US" sz="1800" b="1" dirty="0">
                 <a:solidFill>
                   <a:srgbClr val="5AA9E6"/>
                 </a:solidFill>
@@ -6777,7 +6777,7 @@
               </a:rPr>
               <a:t>Prompt injection</a:t>
             </a:r>
-            <a:endParaRPr lang="en-US" sz="1500" dirty="0"/>
+            <a:endParaRPr lang="en-US" sz="1800" dirty="0"/>
           </a:p>
         </p:txBody>
       </p:sp>
@@ -6806,7 +6806,7 @@
               <a:buNone/>
             </a:pPr>
             <a:r>
-              <a:rPr lang="en-US" sz="1300" dirty="0">
+              <a:rPr lang="en-US" sz="1800" dirty="0">
                 <a:solidFill>
                   <a:srgbClr val="F5F7FA"/>
                 </a:solidFill>
@@ -6816,7 +6816,7 @@
               </a:rPr>
               <a:t>資料變成指令 → 奪取控制</a:t>
             </a:r>
-            <a:endParaRPr lang="en-US" sz="1300" dirty="0"/>
+            <a:endParaRPr lang="en-US" sz="1800" dirty="0"/>
           </a:p>
         </p:txBody>
       </p:sp>
@@ -6872,7 +6872,7 @@
               <a:buNone/>
             </a:pPr>
             <a:r>
-              <a:rPr lang="en-US" sz="1400" b="1" dirty="0">
+              <a:rPr lang="en-US" sz="1800" b="1" dirty="0">
                 <a:solidFill>
                   <a:srgbClr val="F5B82E"/>
                 </a:solidFill>
@@ -6882,7 +6882,7 @@
               </a:rPr>
               <a:t>共同根因:沒把『資料』和『控制』分開。</a:t>
             </a:r>
-            <a:endParaRPr lang="en-US" sz="1400" dirty="0"/>
+            <a:endParaRPr lang="en-US" sz="1800" dirty="0"/>
           </a:p>
         </p:txBody>
       </p:sp>
@@ -6977,7 +6977,7 @@
               <a:buNone/>
             </a:pPr>
             <a:r>
-              <a:rPr lang="en-US" sz="1400" b="1" dirty="0">
+              <a:rPr lang="en-US" sz="1800" b="1" dirty="0">
                 <a:solidFill>
                   <a:srgbClr val="F5F7FA"/>
                 </a:solidFill>
@@ -7001,7 +7001,7 @@
               </a:rPr>
               <a:t>— 惡意指令藏進輸入,蓋過系統提示</a:t>
             </a:r>
-            <a:endParaRPr lang="en-US" sz="1400" dirty="0"/>
+            <a:endParaRPr lang="en-US" sz="1800" dirty="0"/>
           </a:p>
         </p:txBody>
       </p:sp>
@@ -7030,7 +7030,7 @@
               <a:buNone/>
             </a:pPr>
             <a:r>
-              <a:rPr lang="en-US" sz="1400" b="1" dirty="0">
+              <a:rPr lang="en-US" sz="1800" b="1" dirty="0">
                 <a:solidFill>
                   <a:srgbClr val="F5F7FA"/>
                 </a:solidFill>
@@ -7054,7 +7054,7 @@
               </a:rPr>
               <a:t>— LLM 輸出未過濾就被下游信任(XSS/SSRF)</a:t>
             </a:r>
-            <a:endParaRPr lang="en-US" sz="1400" dirty="0"/>
+            <a:endParaRPr lang="en-US" sz="1800" dirty="0"/>
           </a:p>
         </p:txBody>
       </p:sp>
@@ -7083,7 +7083,7 @@
               <a:buNone/>
             </a:pPr>
             <a:r>
-              <a:rPr lang="en-US" sz="1400" b="1" dirty="0">
+              <a:rPr lang="en-US" sz="1800" b="1" dirty="0">
                 <a:solidFill>
                   <a:srgbClr val="F5F7FA"/>
                 </a:solidFill>
@@ -7107,7 +7107,7 @@
               </a:rPr>
               <a:t>— 誘導模型吐出系統提示 / 機密</a:t>
             </a:r>
-            <a:endParaRPr lang="en-US" sz="1400" dirty="0"/>
+            <a:endParaRPr lang="en-US" sz="1800" dirty="0"/>
           </a:p>
         </p:txBody>
       </p:sp>
@@ -7301,7 +7301,7 @@
               <a:buNone/>
             </a:pPr>
             <a:r>
-              <a:rPr lang="en-US" sz="1300" i="1" dirty="0">
+              <a:rPr lang="en-US" sz="1800" i="1" dirty="0">
                 <a:solidFill>
                   <a:srgbClr val="9AA7B5"/>
                 </a:solidFill>
@@ -7311,7 +7311,7 @@
               </a:rPr>
               <a:t>從堆疊到提示詞,核心教訓不變:別讓不受信任的資料變成控制。</a:t>
             </a:r>
-            <a:endParaRPr lang="en-US" sz="1300" dirty="0"/>
+            <a:endParaRPr lang="en-US" sz="1800" dirty="0"/>
           </a:p>
         </p:txBody>
       </p:sp>
@@ -7757,7 +7757,7 @@
               <a:buNone/>
             </a:pPr>
             <a:r>
-              <a:rPr lang="en-US" sz="1500" dirty="0">
+              <a:rPr lang="en-US" sz="1800" dirty="0">
                 <a:solidFill>
                   <a:srgbClr val="F5B82E"/>
                 </a:solidFill>
@@ -7767,7 +7767,7 @@
               </a:rPr>
               <a:t>報告大綱 — 今天的四段路線</a:t>
             </a:r>
-            <a:endParaRPr lang="en-US" sz="1500" dirty="0"/>
+            <a:endParaRPr lang="en-US" sz="1800" dirty="0"/>
           </a:p>
         </p:txBody>
       </p:sp>
@@ -7894,7 +7894,7 @@
               <a:buNone/>
             </a:pPr>
             <a:r>
-              <a:rPr lang="en-US" sz="1400" dirty="0">
+              <a:rPr lang="en-US" sz="1800" dirty="0">
                 <a:solidFill>
                   <a:srgbClr val="9AA7B5"/>
                 </a:solidFill>
@@ -7904,7 +7904,7 @@
               </a:rPr>
               <a:t>為什麼仍然重要 + 關鍵詞(buffer / stack / canary / 139·134)</a:t>
             </a:r>
-            <a:endParaRPr lang="en-US" sz="1400" dirty="0"/>
+            <a:endParaRPr lang="en-US" sz="1800" dirty="0"/>
           </a:p>
         </p:txBody>
       </p:sp>
@@ -8031,7 +8031,7 @@
               <a:buNone/>
             </a:pPr>
             <a:r>
-              <a:rPr lang="en-US" sz="1400" dirty="0">
+              <a:rPr lang="en-US" sz="1800" dirty="0">
                 <a:solidFill>
                   <a:srgbClr val="9AA7B5"/>
                 </a:solidFill>
@@ -8041,7 +8041,7 @@
               </a:rPr>
               <a:t>就這一行 strcpy —— 看它如何打爛堆疊、覆寫回傳位址</a:t>
             </a:r>
-            <a:endParaRPr lang="en-US" sz="1400" dirty="0"/>
+            <a:endParaRPr lang="en-US" sz="1800" dirty="0"/>
           </a:p>
         </p:txBody>
       </p:sp>
@@ -8168,7 +8168,7 @@
               <a:buNone/>
             </a:pPr>
             <a:r>
-              <a:rPr lang="en-US" sz="1400" dirty="0">
+              <a:rPr lang="en-US" sz="1800" dirty="0">
                 <a:solidFill>
                   <a:srgbClr val="9AA7B5"/>
                 </a:solidFill>
@@ -8178,7 +8178,7 @@
               </a:rPr>
               <a:t>Live demo 觸發崩潰(134 vs 139),再從源頭用 strncpy 修好</a:t>
             </a:r>
-            <a:endParaRPr lang="en-US" sz="1400" dirty="0"/>
+            <a:endParaRPr lang="en-US" sz="1800" dirty="0"/>
           </a:p>
         </p:txBody>
       </p:sp>
@@ -8305,7 +8305,7 @@
               <a:buNone/>
             </a:pPr>
             <a:r>
-              <a:rPr lang="en-US" sz="1400" dirty="0">
+              <a:rPr lang="en-US" sz="1800" dirty="0">
                 <a:solidFill>
                   <a:srgbClr val="9AA7B5"/>
                 </a:solidFill>
@@ -8315,7 +8315,7 @@
               </a:rPr>
               <a:t>Rust 記憶體安全、快取計時側信道、Canary/ASLR/DEP·NX</a:t>
             </a:r>
-            <a:endParaRPr lang="en-US" sz="1400" dirty="0"/>
+            <a:endParaRPr lang="en-US" sz="1800" dirty="0"/>
           </a:p>
         </p:txBody>
       </p:sp>
@@ -8532,7 +8532,7 @@
               <a:buNone/>
             </a:pPr>
             <a:r>
-              <a:rPr lang="en-US" sz="1500" dirty="0">
+              <a:rPr lang="en-US" sz="1800" dirty="0">
                 <a:solidFill>
                   <a:srgbClr val="F5B82E"/>
                 </a:solidFill>
@@ -8542,7 +8542,7 @@
               </a:rPr>
               <a:t>為什麼到今天仍然重要</a:t>
             </a:r>
-            <a:endParaRPr lang="en-US" sz="1500" dirty="0"/>
+            <a:endParaRPr lang="en-US" sz="1800" dirty="0"/>
           </a:p>
         </p:txBody>
       </p:sp>
@@ -8637,7 +8637,7 @@
               <a:buNone/>
             </a:pPr>
             <a:r>
-              <a:rPr lang="en-US" sz="1500" dirty="0">
+              <a:rPr lang="en-US" sz="1800" dirty="0">
                 <a:solidFill>
                   <a:srgbClr val="F5F7FA"/>
                 </a:solidFill>
@@ -8647,7 +8647,7 @@
               </a:rPr>
               <a:t>of serious CVEs in C / C++ software are memory-safety bugs</a:t>
             </a:r>
-            <a:endParaRPr lang="en-US" sz="1500" dirty="0"/>
+            <a:endParaRPr lang="en-US" sz="1800" dirty="0"/>
           </a:p>
         </p:txBody>
       </p:sp>
@@ -8798,7 +8798,7 @@
               <a:buNone/>
             </a:pPr>
             <a:r>
-              <a:rPr lang="en-US" sz="1600" b="1" dirty="0">
+              <a:rPr lang="en-US" sz="1800" b="1" dirty="0">
                 <a:solidFill>
                   <a:srgbClr val="F5F7FA"/>
                 </a:solidFill>
@@ -8808,7 +8808,7 @@
               </a:rPr>
               <a:t>Morris Worm</a:t>
             </a:r>
-            <a:endParaRPr lang="en-US" sz="1600" dirty="0"/>
+            <a:endParaRPr lang="en-US" sz="1800" dirty="0"/>
           </a:p>
         </p:txBody>
       </p:sp>
@@ -8942,7 +8942,7 @@
               <a:buNone/>
             </a:pPr>
             <a:r>
-              <a:rPr lang="en-US" sz="1600" b="1" dirty="0">
+              <a:rPr lang="en-US" sz="1800" b="1" dirty="0">
                 <a:solidFill>
                   <a:srgbClr val="F5F7FA"/>
                 </a:solidFill>
@@ -8952,7 +8952,7 @@
               </a:rPr>
               <a:t>Code Red</a:t>
             </a:r>
-            <a:endParaRPr lang="en-US" sz="1600" dirty="0"/>
+            <a:endParaRPr lang="en-US" sz="1800" dirty="0"/>
           </a:p>
         </p:txBody>
       </p:sp>
@@ -9086,7 +9086,7 @@
               <a:buNone/>
             </a:pPr>
             <a:r>
-              <a:rPr lang="en-US" sz="1600" b="1" dirty="0">
+              <a:rPr lang="en-US" sz="1800" b="1" dirty="0">
                 <a:solidFill>
                   <a:srgbClr val="F5F7FA"/>
                 </a:solidFill>
@@ -9096,7 +9096,7 @@
               </a:rPr>
               <a:t>SQL Slammer</a:t>
             </a:r>
-            <a:endParaRPr lang="en-US" sz="1600" dirty="0"/>
+            <a:endParaRPr lang="en-US" sz="1800" dirty="0"/>
           </a:p>
         </p:txBody>
       </p:sp>
@@ -9230,7 +9230,7 @@
               <a:buNone/>
             </a:pPr>
             <a:r>
-              <a:rPr lang="en-US" sz="1600" b="1" dirty="0">
+              <a:rPr lang="en-US" sz="1800" b="1" dirty="0">
                 <a:solidFill>
                   <a:srgbClr val="F5F7FA"/>
                 </a:solidFill>
@@ -9240,7 +9240,7 @@
               </a:rPr>
               <a:t>Still #1</a:t>
             </a:r>
-            <a:endParaRPr lang="en-US" sz="1600" dirty="0"/>
+            <a:endParaRPr lang="en-US" sz="1800" dirty="0"/>
           </a:p>
         </p:txBody>
       </p:sp>
@@ -9496,7 +9496,7 @@
               <a:buNone/>
             </a:pPr>
             <a:r>
-              <a:rPr lang="en-US" sz="1500" dirty="0">
+              <a:rPr lang="en-US" sz="1800" dirty="0">
                 <a:solidFill>
                   <a:srgbClr val="F5B82E"/>
                 </a:solidFill>
@@ -9506,7 +9506,7 @@
               </a:rPr>
               <a:t>名詞解釋 — 先搞懂這些詞</a:t>
             </a:r>
-            <a:endParaRPr lang="en-US" sz="1500" dirty="0"/>
+            <a:endParaRPr lang="en-US" sz="1800" dirty="0"/>
           </a:p>
         </p:txBody>
       </p:sp>
@@ -10693,7 +10693,7 @@
               <a:buNone/>
             </a:pPr>
             <a:r>
-              <a:rPr lang="en-US" sz="1500" dirty="0">
+              <a:rPr lang="en-US" sz="1800" dirty="0">
                 <a:solidFill>
                   <a:srgbClr val="F5B82E"/>
                 </a:solidFill>
@@ -10703,7 +10703,7 @@
               </a:rPr>
               <a:t>漏洞核心:就是這一行</a:t>
             </a:r>
-            <a:endParaRPr lang="en-US" sz="1500" dirty="0"/>
+            <a:endParaRPr lang="en-US" sz="1800" dirty="0"/>
           </a:p>
         </p:txBody>
       </p:sp>
@@ -11006,7 +11006,7 @@
               <a:buNone/>
             </a:pPr>
             <a:r>
-              <a:rPr lang="en-US" sz="1300" dirty="0">
+              <a:rPr lang="en-US" sz="1800" dirty="0">
                 <a:solidFill>
                   <a:srgbClr val="F5F7FA"/>
                 </a:solidFill>
@@ -11016,7 +11016,7 @@
               </a:rPr>
               <a:t>固定大小的堆疊緩衝區 (64 bytes)</a:t>
             </a:r>
-            <a:endParaRPr lang="en-US" sz="1300" dirty="0"/>
+            <a:endParaRPr lang="en-US" sz="1800" dirty="0"/>
           </a:p>
         </p:txBody>
       </p:sp>
@@ -11111,7 +11111,7 @@
               <a:buNone/>
             </a:pPr>
             <a:r>
-              <a:rPr lang="en-US" sz="1300" dirty="0">
+              <a:rPr lang="en-US" sz="1800" dirty="0">
                 <a:solidFill>
                   <a:srgbClr val="F5F7FA"/>
                 </a:solidFill>
@@ -11121,7 +11121,7 @@
               </a:rPr>
               <a:t>複製到遇見 NUL 才停,完全不看目的地大小</a:t>
             </a:r>
-            <a:endParaRPr lang="en-US" sz="1300" dirty="0"/>
+            <a:endParaRPr lang="en-US" sz="1800" dirty="0"/>
           </a:p>
         </p:txBody>
       </p:sp>
@@ -11216,7 +11216,7 @@
               <a:buNone/>
             </a:pPr>
             <a:r>
-              <a:rPr lang="en-US" sz="1300" dirty="0">
+              <a:rPr lang="en-US" sz="1800" dirty="0">
                 <a:solidFill>
                   <a:srgbClr val="F5F7FA"/>
                 </a:solidFill>
@@ -11226,7 +11226,7 @@
               </a:rPr>
               <a:t>送超過 64 bytes 就寫出界,覆寫相鄰堆疊資料</a:t>
             </a:r>
-            <a:endParaRPr lang="en-US" sz="1300" dirty="0"/>
+            <a:endParaRPr lang="en-US" sz="1800" dirty="0"/>
           </a:p>
         </p:txBody>
       </p:sp>
@@ -11443,7 +11443,7 @@
               <a:buNone/>
             </a:pPr>
             <a:r>
-              <a:rPr lang="en-US" sz="1500" dirty="0">
+              <a:rPr lang="en-US" sz="1800" dirty="0">
                 <a:solidFill>
                   <a:srgbClr val="F5B82E"/>
                 </a:solidFill>
@@ -11453,7 +11453,7 @@
               </a:rPr>
               <a:t>溢位如何打爛堆疊</a:t>
             </a:r>
-            <a:endParaRPr lang="en-US" sz="1500" dirty="0"/>
+            <a:endParaRPr lang="en-US" sz="1800" dirty="0"/>
           </a:p>
         </p:txBody>
       </p:sp>
@@ -11546,7 +11546,7 @@
               <a:buNone/>
             </a:pPr>
             <a:r>
-              <a:rPr lang="en-US" sz="1500" b="1" dirty="0">
+              <a:rPr lang="en-US" sz="1800" b="1" dirty="0">
                 <a:solidFill>
                   <a:srgbClr val="FF5C57"/>
                 </a:solidFill>
@@ -11571,7 +11571,7 @@
               </a:rPr>
               <a:t>回傳位址(被覆寫)</a:t>
             </a:r>
-            <a:endParaRPr lang="en-US" sz="1500" dirty="0"/>
+            <a:endParaRPr lang="en-US" sz="1800" dirty="0"/>
           </a:p>
         </p:txBody>
       </p:sp>
@@ -11625,7 +11625,7 @@
               <a:buNone/>
             </a:pPr>
             <a:r>
-              <a:rPr lang="en-US" sz="1300" dirty="0">
+              <a:rPr lang="en-US" sz="1800" dirty="0">
                 <a:solidFill>
                   <a:srgbClr val="9AA7B5"/>
                 </a:solidFill>
@@ -11635,7 +11635,7 @@
               </a:rPr>
               <a:t>saved frame pointer</a:t>
             </a:r>
-            <a:endParaRPr lang="en-US" sz="1300" dirty="0"/>
+            <a:endParaRPr lang="en-US" sz="1800" dirty="0"/>
           </a:p>
         </p:txBody>
       </p:sp>
@@ -11689,7 +11689,7 @@
               <a:buNone/>
             </a:pPr>
             <a:r>
-              <a:rPr lang="en-US" sz="1600" b="1" dirty="0">
+              <a:rPr lang="en-US" sz="1800" b="1" dirty="0">
                 <a:solidFill>
                   <a:srgbClr val="F5B82E"/>
                 </a:solidFill>
@@ -11714,7 +11714,7 @@
               </a:rPr>
               <a:t>strcpy() 從這裡開始往上寫</a:t>
             </a:r>
-            <a:endParaRPr lang="en-US" sz="1600" dirty="0"/>
+            <a:endParaRPr lang="en-US" sz="1800" dirty="0"/>
           </a:p>
         </p:txBody>
       </p:sp>
@@ -11921,7 +11921,7 @@
               <a:buNone/>
             </a:pPr>
             <a:r>
-              <a:rPr lang="en-US" sz="1400" dirty="0">
+              <a:rPr lang="en-US" sz="1800" dirty="0">
                 <a:solidFill>
                   <a:srgbClr val="F5F7FA"/>
                 </a:solidFill>
@@ -11931,7 +11931,7 @@
               </a:rPr>
               <a:t>200 bytes 的 'A' 填滿 64-byte buffer 後繼續往上</a:t>
             </a:r>
-            <a:endParaRPr lang="en-US" sz="1400" dirty="0"/>
+            <a:endParaRPr lang="en-US" sz="1800" dirty="0"/>
           </a:p>
         </p:txBody>
       </p:sp>
@@ -12019,7 +12019,7 @@
               <a:buNone/>
             </a:pPr>
             <a:r>
-              <a:rPr lang="en-US" sz="1400" dirty="0">
+              <a:rPr lang="en-US" sz="1800" dirty="0">
                 <a:solidFill>
                   <a:srgbClr val="F5F7FA"/>
                 </a:solidFill>
@@ -12029,7 +12029,7 @@
               </a:rPr>
               <a:t>frame pointer 與回傳位址被 0x41('A') 覆寫</a:t>
             </a:r>
-            <a:endParaRPr lang="en-US" sz="1400" dirty="0"/>
+            <a:endParaRPr lang="en-US" sz="1800" dirty="0"/>
           </a:p>
         </p:txBody>
       </p:sp>
@@ -12117,7 +12117,7 @@
               <a:buNone/>
             </a:pPr>
             <a:r>
-              <a:rPr lang="en-US" sz="1400" dirty="0">
+              <a:rPr lang="en-US" sz="1800" dirty="0">
                 <a:solidFill>
                   <a:srgbClr val="F5F7FA"/>
                 </a:solidFill>
@@ -12127,7 +12127,7 @@
               </a:rPr>
               <a:t>函式 return 時控制流被破壞 → 崩潰</a:t>
             </a:r>
-            <a:endParaRPr lang="en-US" sz="1400" dirty="0"/>
+            <a:endParaRPr lang="en-US" sz="1800" dirty="0"/>
           </a:p>
         </p:txBody>
       </p:sp>
@@ -12344,7 +12344,7 @@
               <a:buNone/>
             </a:pPr>
             <a:r>
-              <a:rPr lang="en-US" sz="1500" dirty="0">
+              <a:rPr lang="en-US" sz="1800" dirty="0">
                 <a:solidFill>
                   <a:srgbClr val="F5B82E"/>
                 </a:solidFill>
@@ -12354,7 +12354,7 @@
               </a:rPr>
               <a:t>實做一鏡到底 · 切到終端機錄影</a:t>
             </a:r>
-            <a:endParaRPr lang="en-US" sz="1500" dirty="0"/>
+            <a:endParaRPr lang="en-US" sz="1800" dirty="0"/>
           </a:p>
         </p:txBody>
       </p:sp>
@@ -12449,7 +12449,7 @@
               <a:buNone/>
             </a:pPr>
             <a:r>
-              <a:rPr lang="en-US" sz="1700" b="1" dirty="0">
+              <a:rPr lang="en-US" sz="1800" b="1" dirty="0">
                 <a:solidFill>
                   <a:srgbClr val="F5F7FA"/>
                 </a:solidFill>
@@ -12459,7 +12459,7 @@
               </a:rPr>
               <a:t>Normal request</a:t>
             </a:r>
-            <a:endParaRPr lang="en-US" sz="1700" dirty="0"/>
+            <a:endParaRPr lang="en-US" sz="1800" dirty="0"/>
           </a:p>
         </p:txBody>
       </p:sp>
@@ -12762,7 +12762,7 @@
               <a:buNone/>
             </a:pPr>
             <a:r>
-              <a:rPr lang="en-US" sz="1700" b="1" dirty="0">
+              <a:rPr lang="en-US" sz="1800" b="1" dirty="0">
                 <a:solidFill>
                   <a:srgbClr val="F5F7FA"/>
                 </a:solidFill>
@@ -12772,7 +12772,7 @@
               </a:rPr>
               <a:t>Unprotected (no canary)</a:t>
             </a:r>
-            <a:endParaRPr lang="en-US" sz="1700" dirty="0"/>
+            <a:endParaRPr lang="en-US" sz="1800" dirty="0"/>
           </a:p>
         </p:txBody>
       </p:sp>
@@ -13075,7 +13075,7 @@
               <a:buNone/>
             </a:pPr>
             <a:r>
-              <a:rPr lang="en-US" sz="1700" b="1" dirty="0">
+              <a:rPr lang="en-US" sz="1800" b="1" dirty="0">
                 <a:solidFill>
                   <a:srgbClr val="F5F7FA"/>
                 </a:solidFill>
@@ -13085,7 +13085,7 @@
               </a:rPr>
               <a:t>Protected (canary on)</a:t>
             </a:r>
-            <a:endParaRPr lang="en-US" sz="1700" dirty="0"/>
+            <a:endParaRPr lang="en-US" sz="1800" dirty="0"/>
           </a:p>
         </p:txBody>
       </p:sp>
@@ -13510,7 +13510,7 @@
               <a:buNone/>
             </a:pPr>
             <a:r>
-              <a:rPr lang="en-US" sz="1500" dirty="0">
+              <a:rPr lang="en-US" sz="1800" dirty="0">
                 <a:solidFill>
                   <a:srgbClr val="F5B82E"/>
                 </a:solidFill>
@@ -13520,7 +13520,7 @@
               </a:rPr>
               <a:t>縱深防禦:三位一體</a:t>
             </a:r>
-            <a:endParaRPr lang="en-US" sz="1500" dirty="0"/>
+            <a:endParaRPr lang="en-US" sz="1800" dirty="0"/>
           </a:p>
         </p:txBody>
       </p:sp>
@@ -13736,7 +13736,7 @@
               <a:buNone/>
             </a:pPr>
             <a:r>
-              <a:rPr lang="en-US" sz="1300" dirty="0">
+              <a:rPr lang="en-US" sz="1800" dirty="0">
                 <a:solidFill>
                   <a:srgbClr val="F5F7FA"/>
                 </a:solidFill>
@@ -13793,7 +13793,7 @@
               <a:buNone/>
             </a:pPr>
             <a:r>
-              <a:rPr lang="en-US" sz="1300" b="1" dirty="0">
+              <a:rPr lang="en-US" sz="1800" b="1" dirty="0">
                 <a:solidFill>
                   <a:srgbClr val="F5B82E"/>
                 </a:solidFill>
@@ -14019,7 +14019,7 @@
               <a:buNone/>
             </a:pPr>
             <a:r>
-              <a:rPr lang="en-US" sz="1300" dirty="0">
+              <a:rPr lang="en-US" sz="1800" dirty="0">
                 <a:solidFill>
                   <a:srgbClr val="F5F7FA"/>
                 </a:solidFill>
@@ -14076,7 +14076,7 @@
               <a:buNone/>
             </a:pPr>
             <a:r>
-              <a:rPr lang="en-US" sz="1300" b="1" dirty="0">
+              <a:rPr lang="en-US" sz="1800" b="1" dirty="0">
                 <a:solidFill>
                   <a:srgbClr val="5AA9E6"/>
                 </a:solidFill>
@@ -14302,7 +14302,7 @@
               <a:buNone/>
             </a:pPr>
             <a:r>
-              <a:rPr lang="en-US" sz="1300" dirty="0">
+              <a:rPr lang="en-US" sz="1800" dirty="0">
                 <a:solidFill>
                   <a:srgbClr val="F5F7FA"/>
                 </a:solidFill>
@@ -14359,7 +14359,7 @@
               <a:buNone/>
             </a:pPr>
             <a:r>
-              <a:rPr lang="en-US" sz="1300" b="1" dirty="0">
+              <a:rPr lang="en-US" sz="1800" b="1" dirty="0">
                 <a:solidFill>
                   <a:srgbClr val="4FD98A"/>
                 </a:solidFill>
@@ -14398,7 +14398,7 @@
               <a:buNone/>
             </a:pPr>
             <a:r>
-              <a:rPr lang="en-US" sz="1400" i="1" dirty="0">
+              <a:rPr lang="en-US" sz="1800" i="1" dirty="0">
                 <a:solidFill>
                   <a:srgbClr val="9AA7B5"/>
                 </a:solidFill>
@@ -14408,7 +14408,7 @@
               </a:rPr>
               <a:t>未被繞過時,三者合力把『遠端程式碼執行 (RCE)』降級為『崩潰 (DoS)』。</a:t>
             </a:r>
-            <a:endParaRPr lang="en-US" sz="1400" dirty="0"/>
+            <a:endParaRPr lang="en-US" sz="1800" dirty="0"/>
           </a:p>
         </p:txBody>
       </p:sp>
@@ -14625,7 +14625,7 @@
               <a:buNone/>
             </a:pPr>
             <a:r>
-              <a:rPr lang="en-US" sz="1500" dirty="0">
+              <a:rPr lang="en-US" sz="1800" dirty="0">
                 <a:solidFill>
                   <a:srgbClr val="F5B82E"/>
                 </a:solidFill>
@@ -14635,7 +14635,7 @@
               </a:rPr>
               <a:t>第二個實作 — strcpy → strncpy,同一份 200-byte payload</a:t>
             </a:r>
-            <a:endParaRPr lang="en-US" sz="1500" dirty="0"/>
+            <a:endParaRPr lang="en-US" sz="1800" dirty="0"/>
           </a:p>
         </p:txBody>
       </p:sp>
@@ -14691,7 +14691,7 @@
               <a:buNone/>
             </a:pPr>
             <a:r>
-              <a:rPr lang="en-US" sz="1600" b="1" dirty="0">
+              <a:rPr lang="en-US" sz="1800" b="1" dirty="0">
                 <a:solidFill>
                   <a:srgbClr val="FF5C57"/>
                 </a:solidFill>
@@ -14701,7 +14701,7 @@
               </a:rPr>
               <a:t>VULNERABLE — strcpy()</a:t>
             </a:r>
-            <a:endParaRPr lang="en-US" sz="1600" dirty="0"/>
+            <a:endParaRPr lang="en-US" sz="1800" dirty="0"/>
           </a:p>
         </p:txBody>
       </p:sp>
@@ -14819,7 +14819,7 @@
               <a:buNone/>
             </a:pPr>
             <a:r>
-              <a:rPr lang="en-US" sz="1400" b="1" dirty="0">
+              <a:rPr lang="en-US" sz="1800" b="1" dirty="0">
                 <a:solidFill>
                   <a:srgbClr val="FF5C57"/>
                 </a:solidFill>
@@ -14833,7 +14833,7 @@
               <a:buNone/>
             </a:pPr>
             <a:r>
-              <a:rPr lang="en-US" sz="1400" dirty="0">
+              <a:rPr lang="en-US" sz="1800" dirty="0">
                 <a:solidFill>
                   <a:srgbClr val="F5F7FA"/>
                 </a:solidFill>
@@ -14843,7 +14843,7 @@
               </a:rPr>
               <a:t>received 200 bytes</a:t>
             </a:r>
-            <a:endParaRPr lang="en-US" sz="1400" dirty="0"/>
+            <a:endParaRPr lang="en-US" sz="1800" dirty="0"/>
           </a:p>
         </p:txBody>
       </p:sp>
@@ -14872,7 +14872,7 @@
               <a:buNone/>
             </a:pPr>
             <a:r>
-              <a:rPr lang="en-US" sz="1400" b="1" dirty="0">
+              <a:rPr lang="en-US" sz="1800" b="1" dirty="0">
                 <a:solidFill>
                   <a:srgbClr val="FF5C57"/>
                 </a:solidFill>
@@ -14886,7 +14886,7 @@
               <a:buNone/>
             </a:pPr>
             <a:r>
-              <a:rPr lang="en-US" sz="1400" dirty="0">
+              <a:rPr lang="en-US" sz="1800" dirty="0">
                 <a:solidFill>
                   <a:srgbClr val="F5F7FA"/>
                 </a:solidFill>
@@ -14896,7 +14896,7 @@
               </a:rPr>
               <a:t>Segmentation fault</a:t>
             </a:r>
-            <a:endParaRPr lang="en-US" sz="1400" dirty="0"/>
+            <a:endParaRPr lang="en-US" sz="1800" dirty="0"/>
           </a:p>
         </p:txBody>
       </p:sp>
@@ -14925,7 +14925,7 @@
               <a:buNone/>
             </a:pPr>
             <a:r>
-              <a:rPr lang="en-US" sz="1400" b="1" dirty="0">
+              <a:rPr lang="en-US" sz="1800" b="1" dirty="0">
                 <a:solidFill>
                   <a:srgbClr val="FF5C57"/>
                 </a:solidFill>
@@ -14939,7 +14939,7 @@
               <a:buNone/>
             </a:pPr>
             <a:r>
-              <a:rPr lang="en-US" sz="1400" b="1" dirty="0">
+              <a:rPr lang="en-US" sz="1800" b="1" dirty="0">
                 <a:solidFill>
                   <a:srgbClr val="FF5C57"/>
                 </a:solidFill>
@@ -14949,7 +14949,7 @@
               </a:rPr>
               <a:t>exit 139 · server DIED</a:t>
             </a:r>
-            <a:endParaRPr lang="en-US" sz="1400" dirty="0"/>
+            <a:endParaRPr lang="en-US" sz="1800" dirty="0"/>
           </a:p>
         </p:txBody>
       </p:sp>
@@ -15005,7 +15005,7 @@
               <a:buNone/>
             </a:pPr>
             <a:r>
-              <a:rPr lang="en-US" sz="1600" b="1" dirty="0">
+              <a:rPr lang="en-US" sz="1800" b="1" dirty="0">
                 <a:solidFill>
                   <a:srgbClr val="4FD98A"/>
                 </a:solidFill>
@@ -15015,7 +15015,7 @@
               </a:rPr>
               <a:t>FIXED — strncpy()</a:t>
             </a:r>
-            <a:endParaRPr lang="en-US" sz="1600" dirty="0"/>
+            <a:endParaRPr lang="en-US" sz="1800" dirty="0"/>
           </a:p>
         </p:txBody>
       </p:sp>
@@ -15153,7 +15153,7 @@
               <a:buNone/>
             </a:pPr>
             <a:r>
-              <a:rPr lang="en-US" sz="1400" b="1" dirty="0">
+              <a:rPr lang="en-US" sz="1800" b="1" dirty="0">
                 <a:solidFill>
                   <a:srgbClr val="4FD98A"/>
                 </a:solidFill>
@@ -15167,7 +15167,7 @@
               <a:buNone/>
             </a:pPr>
             <a:r>
-              <a:rPr lang="en-US" sz="1400" dirty="0">
+              <a:rPr lang="en-US" sz="1800" dirty="0">
                 <a:solidFill>
                   <a:srgbClr val="F5F7FA"/>
                 </a:solidFill>
@@ -15177,7 +15177,7 @@
               </a:rPr>
               <a:t>kept 63 bytes, truncated</a:t>
             </a:r>
-            <a:endParaRPr lang="en-US" sz="1400" dirty="0"/>
+            <a:endParaRPr lang="en-US" sz="1800" dirty="0"/>
           </a:p>
         </p:txBody>
       </p:sp>
@@ -15206,7 +15206,7 @@
               <a:buNone/>
             </a:pPr>
             <a:r>
-              <a:rPr lang="en-US" sz="1400" b="1" dirty="0">
+              <a:rPr lang="en-US" sz="1800" b="1" dirty="0">
                 <a:solidFill>
                   <a:srgbClr val="4FD98A"/>
                 </a:solidFill>
@@ -15220,7 +15220,7 @@
               <a:buNone/>
             </a:pPr>
             <a:r>
-              <a:rPr lang="en-US" sz="1400" dirty="0">
+              <a:rPr lang="en-US" sz="1800" dirty="0">
                 <a:solidFill>
                   <a:srgbClr val="F5F7FA"/>
                 </a:solidFill>
@@ -15230,7 +15230,7 @@
               </a:rPr>
               <a:t>server replied OK (safe)</a:t>
             </a:r>
-            <a:endParaRPr lang="en-US" sz="1400" dirty="0"/>
+            <a:endParaRPr lang="en-US" sz="1800" dirty="0"/>
           </a:p>
         </p:txBody>
       </p:sp>
@@ -15259,7 +15259,7 @@
               <a:buNone/>
             </a:pPr>
             <a:r>
-              <a:rPr lang="en-US" sz="1400" b="1" dirty="0">
+              <a:rPr lang="en-US" sz="1800" b="1" dirty="0">
                 <a:solidFill>
                   <a:srgbClr val="4FD98A"/>
                 </a:solidFill>
@@ -15273,7 +15273,7 @@
               <a:buNone/>
             </a:pPr>
             <a:r>
-              <a:rPr lang="en-US" sz="1400" b="1" dirty="0">
+              <a:rPr lang="en-US" sz="1800" b="1" dirty="0">
                 <a:solidFill>
                   <a:srgbClr val="4FD98A"/>
                 </a:solidFill>
@@ -15283,7 +15283,7 @@
               </a:rPr>
               <a:t>server SURVIVED</a:t>
             </a:r>
-            <a:endParaRPr lang="en-US" sz="1400" dirty="0"/>
+            <a:endParaRPr lang="en-US" sz="1800" dirty="0"/>
           </a:p>
         </p:txBody>
       </p:sp>
@@ -15312,7 +15312,7 @@
               <a:buNone/>
             </a:pPr>
             <a:r>
-              <a:rPr lang="en-US" sz="1400" i="1" dirty="0">
+              <a:rPr lang="en-US" sz="1800" i="1" dirty="0">
                 <a:solidFill>
                   <a:srgbClr val="9AA7B5"/>
                 </a:solidFill>
@@ -15322,7 +15322,7 @@
               </a:rPr>
               <a:t>防護機制讓它停在崩潰;安全寫法(邊界檢查)直接讓溢位無從發生 —— 這才是根治。</a:t>
             </a:r>
-            <a:endParaRPr lang="en-US" sz="1400" dirty="0"/>
+            <a:endParaRPr lang="en-US" sz="1800" dirty="0"/>
           </a:p>
         </p:txBody>
       </p:sp>

</xml_diff>

<commit_message>
Add repo link to the closing slide
Show github.com/happyfishskin/remote_fight on the Thank You slide so the
audience can open the code; keep the docker one-liner alongside it.

Co-Authored-By: Claude Opus 4.8 <noreply@anthropic.com>
</commit_message>
<xml_diff>
--- a/report.pptx
+++ b/report.pptx
@@ -7550,8 +7550,8 @@
         </p:nvSpPr>
         <p:spPr>
           <a:xfrm>
-            <a:off x="731520" y="4114800"/>
-            <a:ext cx="5669280" cy="566928"/>
+            <a:off x="731520" y="4069080"/>
+            <a:ext cx="6035040" cy="566928"/>
           </a:xfrm>
           <a:prstGeom prst="roundRect">
             <a:avLst>
@@ -7577,24 +7577,24 @@
         </p:nvSpPr>
         <p:spPr>
           <a:xfrm>
-            <a:off x="868680" y="4114800"/>
-            <a:ext cx="5486400" cy="566928"/>
-          </a:xfrm>
-          <a:prstGeom prst="rect">
-            <a:avLst/>
-          </a:prstGeom>
-          <a:noFill/>
-          <a:ln/>
-        </p:spPr>
-        <p:txBody>
-          <a:bodyPr wrap="square" lIns="0" tIns="0" rIns="0" bIns="0" rtlCol="0" anchor="ctr"/>
-          <a:lstStyle/>
-          <a:p>
-            <a:pPr algn="l" indent="0" marL="0">
-              <a:buNone/>
-            </a:pPr>
-            <a:r>
-              <a:rPr lang="en-US" sz="1400" dirty="0">
+            <a:off x="868680" y="4069080"/>
+            <a:ext cx="5852160" cy="566928"/>
+          </a:xfrm>
+          <a:prstGeom prst="rect">
+            <a:avLst/>
+          </a:prstGeom>
+          <a:noFill/>
+          <a:ln/>
+        </p:spPr>
+        <p:txBody>
+          <a:bodyPr wrap="square" lIns="0" tIns="0" rIns="0" bIns="0" rtlCol="0" anchor="ctr"/>
+          <a:lstStyle/>
+          <a:p>
+            <a:pPr algn="l" indent="0" marL="0">
+              <a:buNone/>
+            </a:pPr>
+            <a:r>
+              <a:rPr lang="en-US" sz="1500" dirty="0">
                 <a:solidFill>
                   <a:srgbClr val="4FD98A"/>
                 </a:solidFill>
@@ -7608,7 +7608,7 @@
               <a:buNone/>
             </a:pPr>
             <a:r>
-              <a:rPr lang="en-US" sz="1400" dirty="0">
+              <a:rPr lang="en-US" sz="1500" dirty="0">
                 <a:solidFill>
                   <a:srgbClr val="F5F7FA"/>
                 </a:solidFill>
@@ -7618,19 +7618,99 @@
               </a:rPr>
               <a:t>docker run --rm -it overflow-demo</a:t>
             </a:r>
-            <a:endParaRPr lang="en-US" sz="1400" dirty="0"/>
-          </a:p>
-        </p:txBody>
-      </p:sp>
-      <p:sp>
-        <p:nvSpPr>
-          <p:cNvPr id="6" name="Text 4"/>
-          <p:cNvSpPr txBox="1"/>
-          <p:nvPr/>
-        </p:nvSpPr>
-        <p:spPr>
-          <a:xfrm>
-            <a:off x="749808" y="4937760"/>
+            <a:endParaRPr lang="en-US" sz="1500" dirty="0"/>
+          </a:p>
+        </p:txBody>
+      </p:sp>
+      <p:sp>
+        <p:nvSpPr>
+          <p:cNvPr id="6" name="Shape 4"/>
+          <p:cNvSpPr/>
+          <p:nvPr/>
+        </p:nvSpPr>
+        <p:spPr>
+          <a:xfrm>
+            <a:off x="731520" y="4773168"/>
+            <a:ext cx="6035040" cy="566928"/>
+          </a:xfrm>
+          <a:prstGeom prst="roundRect">
+            <a:avLst>
+              <a:gd name="adj" fmla="val 12903"/>
+            </a:avLst>
+          </a:prstGeom>
+          <a:solidFill>
+            <a:srgbClr val="1B2430"/>
+          </a:solidFill>
+          <a:ln w="12700">
+            <a:solidFill>
+              <a:srgbClr val="4FD98A"/>
+            </a:solidFill>
+            <a:prstDash val="solid"/>
+          </a:ln>
+        </p:spPr>
+      </p:sp>
+      <p:sp>
+        <p:nvSpPr>
+          <p:cNvPr id="7" name="Text 5"/>
+          <p:cNvSpPr txBox="1"/>
+          <p:nvPr/>
+        </p:nvSpPr>
+        <p:spPr>
+          <a:xfrm>
+            <a:off x="868680" y="4773168"/>
+            <a:ext cx="5852160" cy="566928"/>
+          </a:xfrm>
+          <a:prstGeom prst="rect">
+            <a:avLst/>
+          </a:prstGeom>
+          <a:noFill/>
+          <a:ln/>
+        </p:spPr>
+        <p:txBody>
+          <a:bodyPr wrap="square" lIns="0" tIns="0" rIns="0" bIns="0" rtlCol="0" anchor="ctr"/>
+          <a:lstStyle/>
+          <a:p>
+            <a:pPr algn="l" indent="0" marL="0">
+              <a:buNone/>
+            </a:pPr>
+            <a:r>
+              <a:rPr lang="en-US" sz="1500" dirty="0">
+                <a:solidFill>
+                  <a:srgbClr val="4FD98A"/>
+                </a:solidFill>
+                <a:latin typeface="Courier New" pitchFamily="34" charset="0"/>
+                <a:ea typeface="Courier New" pitchFamily="34" charset="-122"/>
+                <a:cs typeface="Courier New" pitchFamily="34" charset="-120"/>
+              </a:rPr>
+              <a:t>code  </a:t>
+            </a:r>
+            <a:pPr algn="l" indent="0" marL="0">
+              <a:buNone/>
+            </a:pPr>
+            <a:r>
+              <a:rPr lang="en-US" sz="1500" dirty="0">
+                <a:solidFill>
+                  <a:srgbClr val="F5F7FA"/>
+                </a:solidFill>
+                <a:latin typeface="Courier New" pitchFamily="34" charset="0"/>
+                <a:ea typeface="Courier New" pitchFamily="34" charset="-122"/>
+                <a:cs typeface="Courier New" pitchFamily="34" charset="-120"/>
+              </a:rPr>
+              <a:t>github.com/happyfishskin/remote_fight</a:t>
+            </a:r>
+            <a:endParaRPr lang="en-US" sz="1500" dirty="0"/>
+          </a:p>
+        </p:txBody>
+      </p:sp>
+      <p:sp>
+        <p:nvSpPr>
+          <p:cNvPr id="8" name="Text 6"/>
+          <p:cNvSpPr txBox="1"/>
+          <p:nvPr/>
+        </p:nvSpPr>
+        <p:spPr>
+          <a:xfrm>
+            <a:off x="749808" y="5577840"/>
             <a:ext cx="10698480" cy="365760"/>
           </a:xfrm>
           <a:prstGeom prst="rect">
@@ -7647,7 +7727,7 @@
               <a:buNone/>
             </a:pPr>
             <a:r>
-              <a:rPr lang="en-US" sz="1300" i="1" dirty="0">
+              <a:rPr lang="en-US" sz="1800" i="1" dirty="0">
                 <a:solidFill>
                   <a:srgbClr val="9AA7B5"/>
                 </a:solidFill>
@@ -7657,7 +7737,7 @@
               </a:rPr>
               <a:t>Demo 全程於隔離 Docker 沙箱執行 · 不含任何 exploit 程式碼</a:t>
             </a:r>
-            <a:endParaRPr lang="en-US" sz="1300" dirty="0"/>
+            <a:endParaRPr lang="en-US" sz="1800" dirty="0"/>
           </a:p>
         </p:txBody>
       </p:sp>

</xml_diff>